<commit_message>
feat: expand i18n framework to all 11 SA official languages (4 validated + 7 first-pass) + SA Sign Language roadmap
</commit_message>
<xml_diff>
--- a/pitch/AI_Tutor_Pitch.pptx
+++ b/pitch/AI_Tutor_Pitch.pptx
@@ -5408,7 +5408,7 @@
                 </a:solidFill>
                 <a:latin typeface="Calibri"/>
               </a:rPr>
-              <a:t>• Multilingual auto-detect (en/af/zu/xh)</a:t>
+              <a:t>• 11 official SA languages framework · 4 launch-validated</a:t>
             </a:r>
           </a:p>
           <a:p>
@@ -5594,7 +5594,7 @@
                 </a:solidFill>
                 <a:latin typeface="Calibri"/>
               </a:rPr>
-              <a:t>• Same 4 languages, native experience</a:t>
+              <a:t>• All 11 official languages on roadmap · 4 launch ready</a:t>
             </a:r>
           </a:p>
           <a:p>
@@ -7507,7 +7507,7 @@
                 </a:solidFill>
                 <a:latin typeface="Calibri"/>
               </a:rPr>
-              <a:t>Phase 2: Grades 8–10 + Maths Literacy. Phase 3: Sciences, Accounting, all 11 official languages.</a:t>
+              <a:t>Phase 2: Grades 8–10 + Maths Literacy. Phase 3: Sciences, Accounting, 11 official spoken languages + SA Sign Language (video channel).</a:t>
             </a:r>
           </a:p>
         </p:txBody>
@@ -7768,7 +7768,7 @@
                 </a:solidFill>
                 <a:latin typeface="Calibri"/>
               </a:rPr>
-              <a:t>• en / af / zu / xh now → 11 langs</a:t>
+              <a:t>• 4 validated + 7 first-pass + SA Sign Language = 12</a:t>
             </a:r>
           </a:p>
           <a:p>
@@ -8753,7 +8753,7 @@
                 </a:solidFill>
                 <a:latin typeface="Calibri"/>
               </a:rPr>
-              <a:t>• All 11 official languages</a:t>
+              <a:t>• All 11 official spoken languages educator-validated + SA Sign Language</a:t>
             </a:r>
           </a:p>
           <a:p>

</xml_diff>

<commit_message>
chore: rebrand to "EduConnect AI Tutor" across code + deck + both channels
</commit_message>
<xml_diff>
--- a/pitch/AI_Tutor_Pitch.pptx
+++ b/pitch/AI_Tutor_Pitch.pptx
@@ -513,7 +513,7 @@
           <a:lstStyle/>
           <a:p>
             <a:r>
-              <a:t>Open with the mission, not the tech. AI Tutor is a public-good tutor that reaches every learner in South Africa — smartphone or feature phone, any of the 11 official languages. The two device mockups are placeholders; final version replaces them with real photos of SA learners using the app. Powered by Dell AI Factory. Zero-rated on Vodacom. CAPS-aligned.</a:t>
+              <a:t>Open with the mission, not the tech. EduConnect AI Tutor is a public-good tutor that reaches every learner in South Africa — smartphone or feature phone, any of the 11 official languages. The two device mockups are placeholders; final version replaces them with real photos of SA learners using the app. Powered by Dell AI Factory. Zero-rated on Vodacom. CAPS-aligned.</a:t>
             </a:r>
           </a:p>
         </p:txBody>
@@ -793,7 +793,7 @@
           <a:lstStyle/>
           <a:p>
             <a:r>
-              <a:t>Open with the equity story. We're a CAPS-aligned multilingual AI tutor that meets every learner — smartphone or feature phone — where they are. Powered by Dell AI Factory. Zero-rated on Vodacom.</a:t>
+              <a:t>Open with the equity story. EduConnect AI Tutor is a CAPS-aligned multilingual tutor that meets every learner — smartphone or feature phone — where they are. Powered by Dell AI Factory. Zero-rated on Vodacom.</a:t>
             </a:r>
           </a:p>
         </p:txBody>
@@ -1073,7 +1073,7 @@
           <a:lstStyle/>
           <a:p>
             <a:r>
-              <a:t>This is the demo you'll record. Six screens, one continuous flow, real NSC content, no answers given away, mark-scheme-authentic. When an executive asks 'is this real?' — this is the slide you point to.</a:t>
+              <a:t>This is the EduConnect demo you'll record. Six screens, one continuous flow, real NSC content, no answers given away, mark-scheme-authentic. When an executive asks 'is this real?' — this is the slide you point to.</a:t>
             </a:r>
           </a:p>
         </p:txBody>
@@ -4372,13 +4372,13 @@
           <a:p>
             <a:pPr algn="l"/>
             <a:r>
-              <a:rPr sz="7200" b="1">
+              <a:rPr sz="5600" b="1">
                 <a:solidFill>
                   <a:srgbClr val="FFFFFF"/>
                 </a:solidFill>
                 <a:latin typeface="Calibri"/>
               </a:rPr>
-              <a:t>AI Tutor</a:t>
+              <a:t>EduConnect AI Tutor</a:t>
             </a:r>
           </a:p>
         </p:txBody>
@@ -6977,13 +6977,13 @@
           <a:p>
             <a:pPr algn="l"/>
             <a:r>
-              <a:rPr sz="7200" b="1">
+              <a:rPr sz="5400" b="1">
                 <a:solidFill>
                   <a:srgbClr val="FFFFFF"/>
                 </a:solidFill>
                 <a:latin typeface="Calibri"/>
               </a:rPr>
-              <a:t>AI Tutor</a:t>
+              <a:t>EduConnect AI Tutor</a:t>
             </a:r>
           </a:p>
         </p:txBody>

</xml_diff>

<commit_message>
feat(pitch): reframe Economics slide with honest R15–R25 today vs R2 target
- Killer band now shows TODAY (~R15–R25 unsubsidised) alongside TARGET (~R2 with Dell + Vodacom) and PRIVATE TUTOR (R16k)
- Cost breakdown updated with realistic ranges based on actual Gemini Flash-Lite, aggregator USSD, Meta WhatsApp Cloud, and Render hosting pricing
- ROI table now includes both EduConnect (today) ~R20 and EduConnect (target) R2 rows
- Added assumptions footnote: ~100 sessions/learner/year is unvalidated; R2 target requires signed partnerships
- Bottom banner reframed: 'Even at 10× today's cost, we're still 80× cheaper than a tutor' — defensible in a CFO Q&A
- Speaker notes rewritten to coach the presenter to lead with the range, not the R2
</commit_message>
<xml_diff>
--- a/pitch/AI_Tutor_Pitch.pptx
+++ b/pitch/AI_Tutor_Pitch.pptx
@@ -1011,7 +1011,7 @@
           <a:lstStyle/>
           <a:p>
             <a:r>
-              <a:t>The R2/learner/year number is the pitch's killer stat. Break it down so the CFO in the room can audit it. Costs are today's Gemini Flash-Lite pilot pricing — they DROP to ~R0.80 on Dell AI Factory NIM (hardware-only cost, no per-token bill). The private-tutor comparison isn't hypothetical — R250-500/hour × ~60 hours/year is the going rate in SA. The break-even framing is roadmap, not shipped: we haven't run the pilot yet, so uplift is a target, not a claim. Rehearse the R2-vs-R16,000 line — that's the mic drop.</a:t>
+              <a:t>Two numbers on this slide, both honest. R15–R25 is TODAY: real Gemini Flash-Lite pricing, real aggregator USSD rates (~R0.05–R0.10 per session), real Meta WhatsApp Cloud rates, real Render/Postgres hosting. R2 is the TARGET — it lands only when Dell donates NIM hardware (drops LLM cost to hardware amortisation only) AND Vodacom absorbs USSD + data charges through the Purpose partnership. Neither is signed. The ~100 sessions/learner/year figure is our modelling assumption — we don't have pilot data yet, so it could be 20 or 300. If a CFO in the room challenges the R2, the honest answer is: 'That's our target with signed partnerships. Unsubsidised today, we're at R15–R25 — and even at 10× that, we're still ~80× cheaper than a private tutor. The economics work at any point in that range.' Don't oversell R2 — the R2-vs-R25 framing is what makes this credible in Q&amp;A.</a:t>
             </a:r>
           </a:p>
         </p:txBody>
@@ -8902,13 +8902,13 @@
           <a:p>
             <a:pPr algn="l"/>
             <a:r>
-              <a:rPr sz="2800" b="1">
+              <a:rPr sz="2400" b="1">
                 <a:solidFill>
                   <a:srgbClr val="FFFFFF"/>
                 </a:solidFill>
                 <a:latin typeface="Calibri"/>
               </a:rPr>
-              <a:t>R2 per learner per year. At scale.</a:t>
+              <a:t>R15–R25 today. R2 target — with Dell + Vodacom in place.</a:t>
             </a:r>
           </a:p>
         </p:txBody>
@@ -9029,7 +9029,7 @@
                 </a:solidFill>
                 <a:latin typeface="Calibri"/>
               </a:rPr>
-              <a:t>COST PER LEARNER / YEAR</a:t>
+              <a:t>TODAY · UNSUBSIDISED PILOT</a:t>
             </a:r>
           </a:p>
         </p:txBody>
@@ -9058,13 +9058,13 @@
           <a:p>
             <a:pPr algn="ctr"/>
             <a:r>
-              <a:rPr sz="4400" b="1">
-                <a:solidFill>
-                  <a:srgbClr val="9CFF8C"/>
-                </a:solidFill>
-                <a:latin typeface="Calibri"/>
-              </a:rPr>
-              <a:t>≈ R2</a:t>
+              <a:rPr sz="3200" b="1">
+                <a:solidFill>
+                  <a:srgbClr val="FFFFFF"/>
+                </a:solidFill>
+                <a:latin typeface="Calibri"/>
+              </a:rPr>
+              <a:t>~R15–R25 / yr</a:t>
             </a:r>
           </a:p>
         </p:txBody>
@@ -9099,7 +9099,7 @@
                 </a:solidFill>
                 <a:latin typeface="Calibri"/>
               </a:rPr>
-              <a:t>100,000 LEARNERS</a:t>
+              <a:t>TARGET · DELL + VODACOM</a:t>
             </a:r>
           </a:p>
         </p:txBody>
@@ -9128,13 +9128,13 @@
           <a:p>
             <a:pPr algn="ctr"/>
             <a:r>
-              <a:rPr sz="3600" b="1">
-                <a:solidFill>
-                  <a:srgbClr val="FFFFFF"/>
-                </a:solidFill>
-                <a:latin typeface="Calibri"/>
-              </a:rPr>
-              <a:t>≈ R200k / yr</a:t>
+              <a:rPr sz="4400" b="1">
+                <a:solidFill>
+                  <a:srgbClr val="9CFF8C"/>
+                </a:solidFill>
+                <a:latin typeface="Calibri"/>
+              </a:rPr>
+              <a:t>~R2 / yr</a:t>
             </a:r>
           </a:p>
         </p:txBody>
@@ -9198,7 +9198,7 @@
           <a:p>
             <a:pPr algn="ctr"/>
             <a:r>
-              <a:rPr sz="3600" b="1">
+              <a:rPr sz="3200" b="1">
                 <a:solidFill>
                   <a:srgbClr val="FFE9B8"/>
                 </a:solidFill>
@@ -9217,7 +9217,7 @@
         </p:nvSpPr>
         <p:spPr>
           <a:xfrm>
-            <a:off x="548640" y="3337560"/>
+            <a:off x="548640" y="3291840"/>
             <a:ext cx="5303520" cy="365760"/>
           </a:xfrm>
           <a:prstGeom prst="rect">
@@ -9233,13 +9233,13 @@
           <a:p>
             <a:pPr algn="l"/>
             <a:r>
-              <a:rPr sz="1500" b="1">
+              <a:rPr sz="1400" b="1">
                 <a:solidFill>
                   <a:srgbClr val="9CFF8C"/>
                 </a:solidFill>
                 <a:latin typeface="Calibri"/>
               </a:rPr>
-              <a:t>What makes up the R2</a:t>
+              <a:t>Today's cost breakdown (unsubsidised)</a:t>
             </a:r>
           </a:p>
         </p:txBody>
@@ -9252,8 +9252,8 @@
         </p:nvSpPr>
         <p:spPr>
           <a:xfrm>
-            <a:off x="548640" y="3794760"/>
-            <a:ext cx="5303520" cy="2743200"/>
+            <a:off x="548640" y="3703320"/>
+            <a:ext cx="5303520" cy="2560320"/>
           </a:xfrm>
           <a:prstGeom prst="rect">
             <a:avLst/>
@@ -9268,97 +9268,97 @@
           <a:p>
             <a:pPr algn="l">
               <a:spcBef>
-                <a:spcPts val="500"/>
+                <a:spcPts val="400"/>
               </a:spcBef>
             </a:pPr>
             <a:r>
-              <a:rPr sz="1200">
+              <a:rPr sz="1100">
                 <a:solidFill>
                   <a:srgbClr val="E9EDEF"/>
                 </a:solidFill>
                 <a:latin typeface="Calibri"/>
               </a:rPr>
-              <a:t>• LLM tokens (Gemini Flash-Lite): ~R1.10 / learner / yr</a:t>
+              <a:t>• LLM tokens (Gemini Flash-Lite): ~R3–R10 / learner / yr</a:t>
             </a:r>
           </a:p>
           <a:p>
             <a:pPr algn="l">
               <a:spcBef>
-                <a:spcPts val="500"/>
+                <a:spcPts val="400"/>
               </a:spcBef>
             </a:pPr>
             <a:r>
-              <a:rPr sz="1200">
+              <a:rPr sz="1100">
                 <a:solidFill>
                   <a:srgbClr val="E9EDEF"/>
                 </a:solidFill>
                 <a:latin typeface="Calibri"/>
               </a:rPr>
-              <a:t>• USSD aggregator (per session): ~R0.40 / learner / yr</a:t>
+              <a:t>• USSD aggregator (per session): ~R5–R10 / learner / yr</a:t>
             </a:r>
           </a:p>
           <a:p>
             <a:pPr algn="l">
               <a:spcBef>
-                <a:spcPts val="500"/>
+                <a:spcPts val="400"/>
               </a:spcBef>
             </a:pPr>
             <a:r>
-              <a:rPr sz="1200">
+              <a:rPr sz="1100">
                 <a:solidFill>
                   <a:srgbClr val="E9EDEF"/>
                 </a:solidFill>
                 <a:latin typeface="Calibri"/>
               </a:rPr>
-              <a:t>• WhatsApp Cloud API + hosting: ~R0.30 / learner / yr</a:t>
+              <a:t>• WhatsApp Cloud API: ~R2–R4 / learner / yr</a:t>
             </a:r>
           </a:p>
           <a:p>
             <a:pPr algn="l">
               <a:spcBef>
-                <a:spcPts val="500"/>
+                <a:spcPts val="400"/>
               </a:spcBef>
             </a:pPr>
             <a:r>
-              <a:rPr sz="1200">
+              <a:rPr sz="1100">
                 <a:solidFill>
                   <a:srgbClr val="E9EDEF"/>
                 </a:solidFill>
                 <a:latin typeface="Calibri"/>
               </a:rPr>
-              <a:t>• Analytics + monitoring + SMS OTP: ~R0.20 / learner / yr</a:t>
+              <a:t>• Hosting + Postgres + Redis: ~R2–R4 / learner / yr</a:t>
             </a:r>
           </a:p>
           <a:p>
             <a:pPr algn="l">
               <a:spcBef>
-                <a:spcPts val="500"/>
+                <a:spcPts val="400"/>
               </a:spcBef>
             </a:pPr>
             <a:r>
-              <a:rPr sz="1200">
+              <a:rPr sz="1100">
                 <a:solidFill>
                   <a:srgbClr val="E9EDEF"/>
                 </a:solidFill>
                 <a:latin typeface="Calibri"/>
               </a:rPr>
-              <a:t>• Assumes: ~100 sessions/learner/year, mixed channels</a:t>
+              <a:t>• Analytics + monitoring + SMS OTP: ~R1–R2 / learner / yr</a:t>
             </a:r>
           </a:p>
           <a:p>
             <a:pPr algn="l">
               <a:spcBef>
-                <a:spcPts val="500"/>
+                <a:spcPts val="400"/>
               </a:spcBef>
             </a:pPr>
             <a:r>
-              <a:rPr sz="1200">
+              <a:rPr sz="1100">
                 <a:solidFill>
                   <a:srgbClr val="E9EDEF"/>
                 </a:solidFill>
                 <a:latin typeface="Calibri"/>
               </a:rPr>
-              <a:t>• At production scale on Dell AI Factory NIM: ~R0.80 / yr</a:t>
+              <a:t>• Path to R2: Dell NIM hardware + Vodacom absorbs USSD/data</a:t>
             </a:r>
           </a:p>
         </p:txBody>
@@ -9371,7 +9371,7 @@
         </p:nvSpPr>
         <p:spPr>
           <a:xfrm>
-            <a:off x="6400800" y="3337560"/>
+            <a:off x="6400800" y="3291840"/>
             <a:ext cx="5303520" cy="365760"/>
           </a:xfrm>
           <a:prstGeom prst="rect">
@@ -9387,7 +9387,7 @@
           <a:p>
             <a:pPr algn="l"/>
             <a:r>
-              <a:rPr sz="1500" b="1">
+              <a:rPr sz="1400" b="1">
                 <a:solidFill>
                   <a:srgbClr val="9CFF8C"/>
                 </a:solidFill>
@@ -9406,8 +9406,8 @@
         </p:nvSpPr>
         <p:spPr>
           <a:xfrm>
-            <a:off x="6400800" y="3794760"/>
-            <a:ext cx="2834640" cy="411480"/>
+            <a:off x="6400800" y="3703320"/>
+            <a:ext cx="2834640" cy="347472"/>
           </a:xfrm>
           <a:prstGeom prst="roundRect">
             <a:avLst/>
@@ -9439,7 +9439,7 @@
           <a:p>
             <a:pPr algn="ctr"/>
             <a:r>
-              <a:rPr sz="1200" b="1">
+              <a:rPr sz="1100" b="1">
                 <a:solidFill>
                   <a:srgbClr val="E9EDEF"/>
                 </a:solidFill>
@@ -9457,8 +9457,8 @@
         </p:nvSpPr>
         <p:spPr>
           <a:xfrm>
-            <a:off x="9326880" y="3794760"/>
-            <a:ext cx="2377440" cy="411480"/>
+            <a:off x="9326880" y="3703320"/>
+            <a:ext cx="2377440" cy="347472"/>
           </a:xfrm>
           <a:prstGeom prst="roundRect">
             <a:avLst/>
@@ -9490,7 +9490,7 @@
           <a:p>
             <a:pPr algn="ctr"/>
             <a:r>
-              <a:rPr sz="1200" b="1">
+              <a:rPr sz="1100" b="1">
                 <a:solidFill>
                   <a:srgbClr val="03110D"/>
                 </a:solidFill>
@@ -9508,8 +9508,8 @@
         </p:nvSpPr>
         <p:spPr>
           <a:xfrm>
-            <a:off x="6400800" y="4343400"/>
-            <a:ext cx="2834640" cy="411480"/>
+            <a:off x="6400800" y="4151376"/>
+            <a:ext cx="2834640" cy="347472"/>
           </a:xfrm>
           <a:prstGeom prst="roundRect">
             <a:avLst/>
@@ -9541,7 +9541,7 @@
           <a:p>
             <a:pPr algn="ctr"/>
             <a:r>
-              <a:rPr sz="1200" b="1">
+              <a:rPr sz="1100" b="1">
                 <a:solidFill>
                   <a:srgbClr val="E9EDEF"/>
                 </a:solidFill>
@@ -9559,8 +9559,8 @@
         </p:nvSpPr>
         <p:spPr>
           <a:xfrm>
-            <a:off x="9326880" y="4343400"/>
-            <a:ext cx="2377440" cy="411480"/>
+            <a:off x="9326880" y="4151376"/>
+            <a:ext cx="2377440" cy="347472"/>
           </a:xfrm>
           <a:prstGeom prst="roundRect">
             <a:avLst/>
@@ -9592,7 +9592,7 @@
           <a:p>
             <a:pPr algn="ctr"/>
             <a:r>
-              <a:rPr sz="1200" b="1">
+              <a:rPr sz="1100" b="1">
                 <a:solidFill>
                   <a:srgbClr val="03110D"/>
                 </a:solidFill>
@@ -9610,8 +9610,8 @@
         </p:nvSpPr>
         <p:spPr>
           <a:xfrm>
-            <a:off x="6400800" y="4892040"/>
-            <a:ext cx="2834640" cy="411480"/>
+            <a:off x="6400800" y="4599432"/>
+            <a:ext cx="2834640" cy="347472"/>
           </a:xfrm>
           <a:prstGeom prst="roundRect">
             <a:avLst/>
@@ -9643,7 +9643,7 @@
           <a:p>
             <a:pPr algn="ctr"/>
             <a:r>
-              <a:rPr sz="1200" b="1">
+              <a:rPr sz="1100" b="1">
                 <a:solidFill>
                   <a:srgbClr val="E9EDEF"/>
                 </a:solidFill>
@@ -9661,8 +9661,8 @@
         </p:nvSpPr>
         <p:spPr>
           <a:xfrm>
-            <a:off x="9326880" y="4892040"/>
-            <a:ext cx="2377440" cy="411480"/>
+            <a:off x="9326880" y="4599432"/>
+            <a:ext cx="2377440" cy="347472"/>
           </a:xfrm>
           <a:prstGeom prst="roundRect">
             <a:avLst/>
@@ -9694,7 +9694,7 @@
           <a:p>
             <a:pPr algn="ctr"/>
             <a:r>
-              <a:rPr sz="1200" b="1">
+              <a:rPr sz="1100" b="1">
                 <a:solidFill>
                   <a:srgbClr val="03110D"/>
                 </a:solidFill>
@@ -9712,8 +9712,8 @@
         </p:nvSpPr>
         <p:spPr>
           <a:xfrm>
-            <a:off x="6400800" y="5440679"/>
-            <a:ext cx="2834640" cy="411480"/>
+            <a:off x="6400800" y="5047488"/>
+            <a:ext cx="2834640" cy="347472"/>
           </a:xfrm>
           <a:prstGeom prst="roundRect">
             <a:avLst/>
@@ -9745,12 +9745,12 @@
           <a:p>
             <a:pPr algn="ctr"/>
             <a:r>
-              <a:rPr sz="1200" b="1">
+              <a:rPr sz="1100" b="1">
                 <a:solidFill>
                   <a:srgbClr val="E9EDEF"/>
                 </a:solidFill>
               </a:rPr>
-              <a:t>EduConnect</a:t>
+              <a:t>EduConnect (today)</a:t>
             </a:r>
           </a:p>
         </p:txBody>
@@ -9763,8 +9763,8 @@
         </p:nvSpPr>
         <p:spPr>
           <a:xfrm>
-            <a:off x="9326880" y="5440679"/>
-            <a:ext cx="2377440" cy="411480"/>
+            <a:off x="9326880" y="5047488"/>
+            <a:ext cx="2377440" cy="347472"/>
           </a:xfrm>
           <a:prstGeom prst="roundRect">
             <a:avLst/>
@@ -9796,11 +9796,113 @@
           <a:p>
             <a:pPr algn="ctr"/>
             <a:r>
-              <a:rPr sz="1200" b="1">
+              <a:rPr sz="1100" b="1">
                 <a:solidFill>
                   <a:srgbClr val="03110D"/>
                 </a:solidFill>
               </a:rPr>
+              <a:t>~R20 / yr</a:t>
+            </a:r>
+          </a:p>
+        </p:txBody>
+      </p:sp>
+      <p:sp>
+        <p:nvSpPr>
+          <p:cNvPr id="23" name="Rounded Rectangle 22"/>
+          <p:cNvSpPr/>
+          <p:nvPr/>
+        </p:nvSpPr>
+        <p:spPr>
+          <a:xfrm>
+            <a:off x="6400800" y="5495544"/>
+            <a:ext cx="2834640" cy="347472"/>
+          </a:xfrm>
+          <a:prstGeom prst="roundRect">
+            <a:avLst/>
+          </a:prstGeom>
+          <a:solidFill>
+            <a:srgbClr val="111B21"/>
+          </a:solidFill>
+          <a:ln>
+            <a:noFill/>
+          </a:ln>
+        </p:spPr>
+        <p:style>
+          <a:lnRef idx="1">
+            <a:schemeClr val="accent1"/>
+          </a:lnRef>
+          <a:fillRef idx="3">
+            <a:schemeClr val="accent1"/>
+          </a:fillRef>
+          <a:effectRef idx="2">
+            <a:schemeClr val="accent1"/>
+          </a:effectRef>
+          <a:fontRef idx="minor">
+            <a:schemeClr val="lt1"/>
+          </a:fontRef>
+        </p:style>
+        <p:txBody>
+          <a:bodyPr rtlCol="0" anchor="ctr" lIns="137160" rIns="137160"/>
+          <a:lstStyle/>
+          <a:p>
+            <a:pPr algn="ctr"/>
+            <a:r>
+              <a:rPr sz="1100" b="1">
+                <a:solidFill>
+                  <a:srgbClr val="E9EDEF"/>
+                </a:solidFill>
+              </a:rPr>
+              <a:t>EduConnect (target)</a:t>
+            </a:r>
+          </a:p>
+        </p:txBody>
+      </p:sp>
+      <p:sp>
+        <p:nvSpPr>
+          <p:cNvPr id="24" name="Rounded Rectangle 23"/>
+          <p:cNvSpPr/>
+          <p:nvPr/>
+        </p:nvSpPr>
+        <p:spPr>
+          <a:xfrm>
+            <a:off x="9326880" y="5495544"/>
+            <a:ext cx="2377440" cy="347472"/>
+          </a:xfrm>
+          <a:prstGeom prst="roundRect">
+            <a:avLst/>
+          </a:prstGeom>
+          <a:solidFill>
+            <a:srgbClr val="00A884"/>
+          </a:solidFill>
+          <a:ln>
+            <a:noFill/>
+          </a:ln>
+        </p:spPr>
+        <p:style>
+          <a:lnRef idx="1">
+            <a:schemeClr val="accent1"/>
+          </a:lnRef>
+          <a:fillRef idx="3">
+            <a:schemeClr val="accent1"/>
+          </a:fillRef>
+          <a:effectRef idx="2">
+            <a:schemeClr val="accent1"/>
+          </a:effectRef>
+          <a:fontRef idx="minor">
+            <a:schemeClr val="lt1"/>
+          </a:fontRef>
+        </p:style>
+        <p:txBody>
+          <a:bodyPr rtlCol="0" anchor="ctr" lIns="137160" rIns="137160"/>
+          <a:lstStyle/>
+          <a:p>
+            <a:pPr algn="ctr"/>
+            <a:r>
+              <a:rPr sz="1100" b="1">
+                <a:solidFill>
+                  <a:srgbClr val="03110D"/>
+                </a:solidFill>
+              </a:rPr>
               <a:t>R2 / yr</a:t>
             </a:r>
           </a:p>
@@ -9808,7 +9910,42 @@
       </p:sp>
       <p:sp>
         <p:nvSpPr>
-          <p:cNvPr id="23" name="Rounded Rectangle 22"/>
+          <p:cNvPr id="25" name="TextBox 24"/>
+          <p:cNvSpPr txBox="1"/>
+          <p:nvPr/>
+        </p:nvSpPr>
+        <p:spPr>
+          <a:xfrm>
+            <a:off x="548640" y="5989320"/>
+            <a:ext cx="11064240" cy="256032"/>
+          </a:xfrm>
+          <a:prstGeom prst="rect">
+            <a:avLst/>
+          </a:prstGeom>
+          <a:noFill/>
+        </p:spPr>
+        <p:txBody>
+          <a:bodyPr wrap="square">
+            <a:spAutoFit/>
+          </a:bodyPr>
+          <a:lstStyle/>
+          <a:p>
+            <a:pPr algn="ctr"/>
+            <a:r>
+              <a:rPr sz="900" b="0">
+                <a:solidFill>
+                  <a:srgbClr val="8696A0"/>
+                </a:solidFill>
+                <a:latin typeface="Calibri"/>
+              </a:rPr>
+              <a:t>Assumes: ~100 sessions/learner/year (unvalidated) · Dell hardware sponsorship + Vodacom absorbing USSD/data to reach the R2 target</a:t>
+            </a:r>
+          </a:p>
+        </p:txBody>
+      </p:sp>
+      <p:sp>
+        <p:nvSpPr>
+          <p:cNvPr id="26" name="Rounded Rectangle 25"/>
           <p:cNvSpPr/>
           <p:nvPr/>
         </p:nvSpPr>
@@ -9851,7 +9988,7 @@
       </p:sp>
       <p:sp>
         <p:nvSpPr>
-          <p:cNvPr id="24" name="TextBox 23"/>
+          <p:cNvPr id="27" name="TextBox 26"/>
           <p:cNvSpPr txBox="1"/>
           <p:nvPr/>
         </p:nvSpPr>
@@ -9879,7 +10016,7 @@
                 </a:solidFill>
                 <a:latin typeface="Calibri"/>
               </a:rPr>
-              <a:t>1 extra matric pass generates ~R150k lifetime earnings uplift. Break-even at ~1 additional pass per 75,000 learners served.</a:t>
+              <a:t>Even at 10× today's cost (~R200/yr), we're still 80× cheaper than a tutor. 1 extra matric pass = ~R150k lifetime earnings uplift — break-even at ~1 pass per 75k learners.</a:t>
             </a:r>
           </a:p>
         </p:txBody>

</xml_diff>